<commit_message>
update: update README, PNGs, and slides
</commit_message>
<xml_diff>
--- a/slides.pptx
+++ b/slides.pptx
@@ -136,123 +136,6 @@
 <file path=ppt/changesInfos/changesInfo1.xml><?xml version="1.0" encoding="utf-8"?>
 <pc:chgInfo xmlns:a="http://schemas.openxmlformats.org/drawingml/2006/main" xmlns:r="http://schemas.openxmlformats.org/officeDocument/2006/relationships" xmlns:ac="http://schemas.microsoft.com/office/drawing/2013/main/command" xmlns:pc="http://schemas.microsoft.com/office/powerpoint/2013/main/command">
   <pc:docChgLst>
-    <pc:chgData name="Nitzan" userId="c6f4b9ed-2c00-430b-ae2d-675e9e5eba4f" providerId="ADAL" clId="{7E7D16A4-A1AB-40AA-BA80-DFB3D6FA62E4}"/>
-    <pc:docChg chg="custSel addSld modSld sldOrd">
-      <pc:chgData name="Nitzan" userId="c6f4b9ed-2c00-430b-ae2d-675e9e5eba4f" providerId="ADAL" clId="{7E7D16A4-A1AB-40AA-BA80-DFB3D6FA62E4}" dt="2022-01-11T09:34:38.830" v="105" actId="1076"/>
-      <pc:docMkLst>
-        <pc:docMk/>
-      </pc:docMkLst>
-      <pc:sldChg chg="modSp mod">
-        <pc:chgData name="Nitzan" userId="c6f4b9ed-2c00-430b-ae2d-675e9e5eba4f" providerId="ADAL" clId="{7E7D16A4-A1AB-40AA-BA80-DFB3D6FA62E4}" dt="2022-01-11T09:30:27.232" v="21" actId="20577"/>
-        <pc:sldMkLst>
-          <pc:docMk/>
-          <pc:sldMk cId="2727192941" sldId="257"/>
-        </pc:sldMkLst>
-        <pc:spChg chg="mod">
-          <ac:chgData name="Nitzan" userId="c6f4b9ed-2c00-430b-ae2d-675e9e5eba4f" providerId="ADAL" clId="{7E7D16A4-A1AB-40AA-BA80-DFB3D6FA62E4}" dt="2022-01-11T09:30:27.232" v="21" actId="20577"/>
-          <ac:spMkLst>
-            <pc:docMk/>
-            <pc:sldMk cId="2727192941" sldId="257"/>
-            <ac:spMk id="2" creationId="{271C905E-90FE-4FEA-A334-AFB4B7F4D610}"/>
-          </ac:spMkLst>
-        </pc:spChg>
-      </pc:sldChg>
-      <pc:sldChg chg="addSp delSp modSp add mod">
-        <pc:chgData name="Nitzan" userId="c6f4b9ed-2c00-430b-ae2d-675e9e5eba4f" providerId="ADAL" clId="{7E7D16A4-A1AB-40AA-BA80-DFB3D6FA62E4}" dt="2022-01-11T09:33:40.380" v="73" actId="1076"/>
-        <pc:sldMkLst>
-          <pc:docMk/>
-          <pc:sldMk cId="3484230388" sldId="258"/>
-        </pc:sldMkLst>
-        <pc:spChg chg="mod">
-          <ac:chgData name="Nitzan" userId="c6f4b9ed-2c00-430b-ae2d-675e9e5eba4f" providerId="ADAL" clId="{7E7D16A4-A1AB-40AA-BA80-DFB3D6FA62E4}" dt="2022-01-11T09:31:08.304" v="60" actId="1076"/>
-          <ac:spMkLst>
-            <pc:docMk/>
-            <pc:sldMk cId="3484230388" sldId="258"/>
-            <ac:spMk id="2" creationId="{271C905E-90FE-4FEA-A334-AFB4B7F4D610}"/>
-          </ac:spMkLst>
-        </pc:spChg>
-        <pc:spChg chg="mod">
-          <ac:chgData name="Nitzan" userId="c6f4b9ed-2c00-430b-ae2d-675e9e5eba4f" providerId="ADAL" clId="{7E7D16A4-A1AB-40AA-BA80-DFB3D6FA62E4}" dt="2022-01-11T09:32:48.520" v="63" actId="313"/>
-          <ac:spMkLst>
-            <pc:docMk/>
-            <pc:sldMk cId="3484230388" sldId="258"/>
-            <ac:spMk id="4" creationId="{11254D5E-1A37-49FD-82D3-351F01110A39}"/>
-          </ac:spMkLst>
-        </pc:spChg>
-        <pc:picChg chg="del">
-          <ac:chgData name="Nitzan" userId="c6f4b9ed-2c00-430b-ae2d-675e9e5eba4f" providerId="ADAL" clId="{7E7D16A4-A1AB-40AA-BA80-DFB3D6FA62E4}" dt="2022-01-11T09:32:51.995" v="64" actId="478"/>
-          <ac:picMkLst>
-            <pc:docMk/>
-            <pc:sldMk cId="3484230388" sldId="258"/>
-            <ac:picMk id="1026" creationId="{D0268B57-6DDE-43B8-88FA-5CAA527D4604}"/>
-          </ac:picMkLst>
-        </pc:picChg>
-        <pc:picChg chg="add del mod">
-          <ac:chgData name="Nitzan" userId="c6f4b9ed-2c00-430b-ae2d-675e9e5eba4f" providerId="ADAL" clId="{7E7D16A4-A1AB-40AA-BA80-DFB3D6FA62E4}" dt="2022-01-11T09:33:40.380" v="73" actId="1076"/>
-          <ac:picMkLst>
-            <pc:docMk/>
-            <pc:sldMk cId="3484230388" sldId="258"/>
-            <ac:picMk id="2050" creationId="{5630289D-F068-46E0-82A3-87CFB5DD7AA3}"/>
-          </ac:picMkLst>
-        </pc:picChg>
-      </pc:sldChg>
-      <pc:sldChg chg="delSp modSp new mod">
-        <pc:chgData name="Nitzan" userId="c6f4b9ed-2c00-430b-ae2d-675e9e5eba4f" providerId="ADAL" clId="{7E7D16A4-A1AB-40AA-BA80-DFB3D6FA62E4}" dt="2022-01-11T09:33:58.140" v="87" actId="478"/>
-        <pc:sldMkLst>
-          <pc:docMk/>
-          <pc:sldMk cId="3982802005" sldId="259"/>
-        </pc:sldMkLst>
-        <pc:spChg chg="mod">
-          <ac:chgData name="Nitzan" userId="c6f4b9ed-2c00-430b-ae2d-675e9e5eba4f" providerId="ADAL" clId="{7E7D16A4-A1AB-40AA-BA80-DFB3D6FA62E4}" dt="2022-01-11T09:33:55.336" v="86" actId="20577"/>
-          <ac:spMkLst>
-            <pc:docMk/>
-            <pc:sldMk cId="3982802005" sldId="259"/>
-            <ac:spMk id="2" creationId="{730C987A-8020-47EF-9907-29D3DCFE70E7}"/>
-          </ac:spMkLst>
-        </pc:spChg>
-        <pc:spChg chg="del">
-          <ac:chgData name="Nitzan" userId="c6f4b9ed-2c00-430b-ae2d-675e9e5eba4f" providerId="ADAL" clId="{7E7D16A4-A1AB-40AA-BA80-DFB3D6FA62E4}" dt="2022-01-11T09:33:58.140" v="87" actId="478"/>
-          <ac:spMkLst>
-            <pc:docMk/>
-            <pc:sldMk cId="3982802005" sldId="259"/>
-            <ac:spMk id="3" creationId="{D6A520A7-1485-4AEB-8B47-085202132B59}"/>
-          </ac:spMkLst>
-        </pc:spChg>
-      </pc:sldChg>
-      <pc:sldChg chg="addSp delSp modSp new mod ord">
-        <pc:chgData name="Nitzan" userId="c6f4b9ed-2c00-430b-ae2d-675e9e5eba4f" providerId="ADAL" clId="{7E7D16A4-A1AB-40AA-BA80-DFB3D6FA62E4}" dt="2022-01-11T09:34:38.830" v="105" actId="1076"/>
-        <pc:sldMkLst>
-          <pc:docMk/>
-          <pc:sldMk cId="4039449901" sldId="260"/>
-        </pc:sldMkLst>
-        <pc:spChg chg="mod">
-          <ac:chgData name="Nitzan" userId="c6f4b9ed-2c00-430b-ae2d-675e9e5eba4f" providerId="ADAL" clId="{7E7D16A4-A1AB-40AA-BA80-DFB3D6FA62E4}" dt="2022-01-11T09:34:34.078" v="102" actId="20577"/>
-          <ac:spMkLst>
-            <pc:docMk/>
-            <pc:sldMk cId="4039449901" sldId="260"/>
-            <ac:spMk id="2" creationId="{18FAE654-BFBD-4E60-8E22-B0A1141C6815}"/>
-          </ac:spMkLst>
-        </pc:spChg>
-        <pc:spChg chg="del">
-          <ac:chgData name="Nitzan" userId="c6f4b9ed-2c00-430b-ae2d-675e9e5eba4f" providerId="ADAL" clId="{7E7D16A4-A1AB-40AA-BA80-DFB3D6FA62E4}" dt="2022-01-11T09:34:37.156" v="103" actId="478"/>
-          <ac:spMkLst>
-            <pc:docMk/>
-            <pc:sldMk cId="4039449901" sldId="260"/>
-            <ac:spMk id="3" creationId="{106A01EB-CC09-4207-8F92-35E4300337D1}"/>
-          </ac:spMkLst>
-        </pc:spChg>
-        <pc:picChg chg="add mod">
-          <ac:chgData name="Nitzan" userId="c6f4b9ed-2c00-430b-ae2d-675e9e5eba4f" providerId="ADAL" clId="{7E7D16A4-A1AB-40AA-BA80-DFB3D6FA62E4}" dt="2022-01-11T09:34:38.830" v="105" actId="1076"/>
-          <ac:picMkLst>
-            <pc:docMk/>
-            <pc:sldMk cId="4039449901" sldId="260"/>
-            <ac:picMk id="5" creationId="{DFCCD338-E36A-447D-B109-D5C9245D52EC}"/>
-          </ac:picMkLst>
-        </pc:picChg>
-      </pc:sldChg>
-    </pc:docChg>
-  </pc:docChgLst>
-  <pc:docChgLst>
     <pc:chgData name="Nitzan" userId="c6f4b9ed-2c00-430b-ae2d-675e9e5eba4f" providerId="ADAL" clId="{28177BFD-E31E-4889-94FB-C3F3258A7F51}"/>
     <pc:docChg chg="undo custSel addSld delSld modSld sldOrd">
       <pc:chgData name="Nitzan" userId="c6f4b9ed-2c00-430b-ae2d-675e9e5eba4f" providerId="ADAL" clId="{28177BFD-E31E-4889-94FB-C3F3258A7F51}" dt="2022-01-25T12:16:02.803" v="1887" actId="1076"/>
@@ -1706,6 +1589,123 @@
             <ac:inkMk id="75" creationId="{2CEF958A-17D6-425F-86F5-FA17EAB2E469}"/>
           </ac:inkMkLst>
         </pc:inkChg>
+      </pc:sldChg>
+    </pc:docChg>
+  </pc:docChgLst>
+  <pc:docChgLst>
+    <pc:chgData name="Nitzan" userId="c6f4b9ed-2c00-430b-ae2d-675e9e5eba4f" providerId="ADAL" clId="{7E7D16A4-A1AB-40AA-BA80-DFB3D6FA62E4}"/>
+    <pc:docChg chg="custSel addSld modSld sldOrd">
+      <pc:chgData name="Nitzan" userId="c6f4b9ed-2c00-430b-ae2d-675e9e5eba4f" providerId="ADAL" clId="{7E7D16A4-A1AB-40AA-BA80-DFB3D6FA62E4}" dt="2022-01-11T09:34:38.830" v="105" actId="1076"/>
+      <pc:docMkLst>
+        <pc:docMk/>
+      </pc:docMkLst>
+      <pc:sldChg chg="modSp mod">
+        <pc:chgData name="Nitzan" userId="c6f4b9ed-2c00-430b-ae2d-675e9e5eba4f" providerId="ADAL" clId="{7E7D16A4-A1AB-40AA-BA80-DFB3D6FA62E4}" dt="2022-01-11T09:30:27.232" v="21" actId="20577"/>
+        <pc:sldMkLst>
+          <pc:docMk/>
+          <pc:sldMk cId="2727192941" sldId="257"/>
+        </pc:sldMkLst>
+        <pc:spChg chg="mod">
+          <ac:chgData name="Nitzan" userId="c6f4b9ed-2c00-430b-ae2d-675e9e5eba4f" providerId="ADAL" clId="{7E7D16A4-A1AB-40AA-BA80-DFB3D6FA62E4}" dt="2022-01-11T09:30:27.232" v="21" actId="20577"/>
+          <ac:spMkLst>
+            <pc:docMk/>
+            <pc:sldMk cId="2727192941" sldId="257"/>
+            <ac:spMk id="2" creationId="{271C905E-90FE-4FEA-A334-AFB4B7F4D610}"/>
+          </ac:spMkLst>
+        </pc:spChg>
+      </pc:sldChg>
+      <pc:sldChg chg="addSp delSp modSp add mod">
+        <pc:chgData name="Nitzan" userId="c6f4b9ed-2c00-430b-ae2d-675e9e5eba4f" providerId="ADAL" clId="{7E7D16A4-A1AB-40AA-BA80-DFB3D6FA62E4}" dt="2022-01-11T09:33:40.380" v="73" actId="1076"/>
+        <pc:sldMkLst>
+          <pc:docMk/>
+          <pc:sldMk cId="3484230388" sldId="258"/>
+        </pc:sldMkLst>
+        <pc:spChg chg="mod">
+          <ac:chgData name="Nitzan" userId="c6f4b9ed-2c00-430b-ae2d-675e9e5eba4f" providerId="ADAL" clId="{7E7D16A4-A1AB-40AA-BA80-DFB3D6FA62E4}" dt="2022-01-11T09:31:08.304" v="60" actId="1076"/>
+          <ac:spMkLst>
+            <pc:docMk/>
+            <pc:sldMk cId="3484230388" sldId="258"/>
+            <ac:spMk id="2" creationId="{271C905E-90FE-4FEA-A334-AFB4B7F4D610}"/>
+          </ac:spMkLst>
+        </pc:spChg>
+        <pc:spChg chg="mod">
+          <ac:chgData name="Nitzan" userId="c6f4b9ed-2c00-430b-ae2d-675e9e5eba4f" providerId="ADAL" clId="{7E7D16A4-A1AB-40AA-BA80-DFB3D6FA62E4}" dt="2022-01-11T09:32:48.520" v="63" actId="313"/>
+          <ac:spMkLst>
+            <pc:docMk/>
+            <pc:sldMk cId="3484230388" sldId="258"/>
+            <ac:spMk id="4" creationId="{11254D5E-1A37-49FD-82D3-351F01110A39}"/>
+          </ac:spMkLst>
+        </pc:spChg>
+        <pc:picChg chg="del">
+          <ac:chgData name="Nitzan" userId="c6f4b9ed-2c00-430b-ae2d-675e9e5eba4f" providerId="ADAL" clId="{7E7D16A4-A1AB-40AA-BA80-DFB3D6FA62E4}" dt="2022-01-11T09:32:51.995" v="64" actId="478"/>
+          <ac:picMkLst>
+            <pc:docMk/>
+            <pc:sldMk cId="3484230388" sldId="258"/>
+            <ac:picMk id="1026" creationId="{D0268B57-6DDE-43B8-88FA-5CAA527D4604}"/>
+          </ac:picMkLst>
+        </pc:picChg>
+        <pc:picChg chg="add del mod">
+          <ac:chgData name="Nitzan" userId="c6f4b9ed-2c00-430b-ae2d-675e9e5eba4f" providerId="ADAL" clId="{7E7D16A4-A1AB-40AA-BA80-DFB3D6FA62E4}" dt="2022-01-11T09:33:40.380" v="73" actId="1076"/>
+          <ac:picMkLst>
+            <pc:docMk/>
+            <pc:sldMk cId="3484230388" sldId="258"/>
+            <ac:picMk id="2050" creationId="{5630289D-F068-46E0-82A3-87CFB5DD7AA3}"/>
+          </ac:picMkLst>
+        </pc:picChg>
+      </pc:sldChg>
+      <pc:sldChg chg="delSp modSp new mod">
+        <pc:chgData name="Nitzan" userId="c6f4b9ed-2c00-430b-ae2d-675e9e5eba4f" providerId="ADAL" clId="{7E7D16A4-A1AB-40AA-BA80-DFB3D6FA62E4}" dt="2022-01-11T09:33:58.140" v="87" actId="478"/>
+        <pc:sldMkLst>
+          <pc:docMk/>
+          <pc:sldMk cId="3982802005" sldId="259"/>
+        </pc:sldMkLst>
+        <pc:spChg chg="mod">
+          <ac:chgData name="Nitzan" userId="c6f4b9ed-2c00-430b-ae2d-675e9e5eba4f" providerId="ADAL" clId="{7E7D16A4-A1AB-40AA-BA80-DFB3D6FA62E4}" dt="2022-01-11T09:33:55.336" v="86" actId="20577"/>
+          <ac:spMkLst>
+            <pc:docMk/>
+            <pc:sldMk cId="3982802005" sldId="259"/>
+            <ac:spMk id="2" creationId="{730C987A-8020-47EF-9907-29D3DCFE70E7}"/>
+          </ac:spMkLst>
+        </pc:spChg>
+        <pc:spChg chg="del">
+          <ac:chgData name="Nitzan" userId="c6f4b9ed-2c00-430b-ae2d-675e9e5eba4f" providerId="ADAL" clId="{7E7D16A4-A1AB-40AA-BA80-DFB3D6FA62E4}" dt="2022-01-11T09:33:58.140" v="87" actId="478"/>
+          <ac:spMkLst>
+            <pc:docMk/>
+            <pc:sldMk cId="3982802005" sldId="259"/>
+            <ac:spMk id="3" creationId="{D6A520A7-1485-4AEB-8B47-085202132B59}"/>
+          </ac:spMkLst>
+        </pc:spChg>
+      </pc:sldChg>
+      <pc:sldChg chg="addSp delSp modSp new mod ord">
+        <pc:chgData name="Nitzan" userId="c6f4b9ed-2c00-430b-ae2d-675e9e5eba4f" providerId="ADAL" clId="{7E7D16A4-A1AB-40AA-BA80-DFB3D6FA62E4}" dt="2022-01-11T09:34:38.830" v="105" actId="1076"/>
+        <pc:sldMkLst>
+          <pc:docMk/>
+          <pc:sldMk cId="4039449901" sldId="260"/>
+        </pc:sldMkLst>
+        <pc:spChg chg="mod">
+          <ac:chgData name="Nitzan" userId="c6f4b9ed-2c00-430b-ae2d-675e9e5eba4f" providerId="ADAL" clId="{7E7D16A4-A1AB-40AA-BA80-DFB3D6FA62E4}" dt="2022-01-11T09:34:34.078" v="102" actId="20577"/>
+          <ac:spMkLst>
+            <pc:docMk/>
+            <pc:sldMk cId="4039449901" sldId="260"/>
+            <ac:spMk id="2" creationId="{18FAE654-BFBD-4E60-8E22-B0A1141C6815}"/>
+          </ac:spMkLst>
+        </pc:spChg>
+        <pc:spChg chg="del">
+          <ac:chgData name="Nitzan" userId="c6f4b9ed-2c00-430b-ae2d-675e9e5eba4f" providerId="ADAL" clId="{7E7D16A4-A1AB-40AA-BA80-DFB3D6FA62E4}" dt="2022-01-11T09:34:37.156" v="103" actId="478"/>
+          <ac:spMkLst>
+            <pc:docMk/>
+            <pc:sldMk cId="4039449901" sldId="260"/>
+            <ac:spMk id="3" creationId="{106A01EB-CC09-4207-8F92-35E4300337D1}"/>
+          </ac:spMkLst>
+        </pc:spChg>
+        <pc:picChg chg="add mod">
+          <ac:chgData name="Nitzan" userId="c6f4b9ed-2c00-430b-ae2d-675e9e5eba4f" providerId="ADAL" clId="{7E7D16A4-A1AB-40AA-BA80-DFB3D6FA62E4}" dt="2022-01-11T09:34:38.830" v="105" actId="1076"/>
+          <ac:picMkLst>
+            <pc:docMk/>
+            <pc:sldMk cId="4039449901" sldId="260"/>
+            <ac:picMk id="5" creationId="{DFCCD338-E36A-447D-B109-D5C9245D52EC}"/>
+          </ac:picMkLst>
+        </pc:picChg>
       </pc:sldChg>
     </pc:docChg>
   </pc:docChgLst>
@@ -1910,7 +1910,7 @@
           <a:p>
             <a:fld id="{27D8F877-061F-4F1B-ABEB-F2386F6B7DA6}" type="datetimeFigureOut">
               <a:rPr lang="en-GB" smtClean="0"/>
-              <a:t>25/01/2022</a:t>
+              <a:t>29/04/2025</a:t>
             </a:fld>
             <a:endParaRPr lang="en-GB"/>
           </a:p>
@@ -2441,7 +2441,7 @@
           <a:p>
             <a:fld id="{E11858CF-6056-43B6-9057-C3E571ECFE2F}" type="datetimeFigureOut">
               <a:rPr lang="en-GB" smtClean="0"/>
-              <a:t>25/01/2022</a:t>
+              <a:t>29/04/2025</a:t>
             </a:fld>
             <a:endParaRPr lang="en-GB"/>
           </a:p>
@@ -2641,7 +2641,7 @@
           <a:p>
             <a:fld id="{E11858CF-6056-43B6-9057-C3E571ECFE2F}" type="datetimeFigureOut">
               <a:rPr lang="en-GB" smtClean="0"/>
-              <a:t>25/01/2022</a:t>
+              <a:t>29/04/2025</a:t>
             </a:fld>
             <a:endParaRPr lang="en-GB"/>
           </a:p>
@@ -2851,7 +2851,7 @@
           <a:p>
             <a:fld id="{E11858CF-6056-43B6-9057-C3E571ECFE2F}" type="datetimeFigureOut">
               <a:rPr lang="en-GB" smtClean="0"/>
-              <a:t>25/01/2022</a:t>
+              <a:t>29/04/2025</a:t>
             </a:fld>
             <a:endParaRPr lang="en-GB"/>
           </a:p>
@@ -3051,7 +3051,7 @@
           <a:p>
             <a:fld id="{E11858CF-6056-43B6-9057-C3E571ECFE2F}" type="datetimeFigureOut">
               <a:rPr lang="en-GB" smtClean="0"/>
-              <a:t>25/01/2022</a:t>
+              <a:t>29/04/2025</a:t>
             </a:fld>
             <a:endParaRPr lang="en-GB"/>
           </a:p>
@@ -3327,7 +3327,7 @@
           <a:p>
             <a:fld id="{E11858CF-6056-43B6-9057-C3E571ECFE2F}" type="datetimeFigureOut">
               <a:rPr lang="en-GB" smtClean="0"/>
-              <a:t>25/01/2022</a:t>
+              <a:t>29/04/2025</a:t>
             </a:fld>
             <a:endParaRPr lang="en-GB"/>
           </a:p>
@@ -3595,7 +3595,7 @@
           <a:p>
             <a:fld id="{E11858CF-6056-43B6-9057-C3E571ECFE2F}" type="datetimeFigureOut">
               <a:rPr lang="en-GB" smtClean="0"/>
-              <a:t>25/01/2022</a:t>
+              <a:t>29/04/2025</a:t>
             </a:fld>
             <a:endParaRPr lang="en-GB"/>
           </a:p>
@@ -4010,7 +4010,7 @@
           <a:p>
             <a:fld id="{E11858CF-6056-43B6-9057-C3E571ECFE2F}" type="datetimeFigureOut">
               <a:rPr lang="en-GB" smtClean="0"/>
-              <a:t>25/01/2022</a:t>
+              <a:t>29/04/2025</a:t>
             </a:fld>
             <a:endParaRPr lang="en-GB"/>
           </a:p>
@@ -4152,7 +4152,7 @@
           <a:p>
             <a:fld id="{E11858CF-6056-43B6-9057-C3E571ECFE2F}" type="datetimeFigureOut">
               <a:rPr lang="en-GB" smtClean="0"/>
-              <a:t>25/01/2022</a:t>
+              <a:t>29/04/2025</a:t>
             </a:fld>
             <a:endParaRPr lang="en-GB"/>
           </a:p>
@@ -4265,7 +4265,7 @@
           <a:p>
             <a:fld id="{E11858CF-6056-43B6-9057-C3E571ECFE2F}" type="datetimeFigureOut">
               <a:rPr lang="en-GB" smtClean="0"/>
-              <a:t>25/01/2022</a:t>
+              <a:t>29/04/2025</a:t>
             </a:fld>
             <a:endParaRPr lang="en-GB"/>
           </a:p>
@@ -4578,7 +4578,7 @@
           <a:p>
             <a:fld id="{E11858CF-6056-43B6-9057-C3E571ECFE2F}" type="datetimeFigureOut">
               <a:rPr lang="en-GB" smtClean="0"/>
-              <a:t>25/01/2022</a:t>
+              <a:t>29/04/2025</a:t>
             </a:fld>
             <a:endParaRPr lang="en-GB"/>
           </a:p>
@@ -4867,7 +4867,7 @@
           <a:p>
             <a:fld id="{E11858CF-6056-43B6-9057-C3E571ECFE2F}" type="datetimeFigureOut">
               <a:rPr lang="en-GB" smtClean="0"/>
-              <a:t>25/01/2022</a:t>
+              <a:t>29/04/2025</a:t>
             </a:fld>
             <a:endParaRPr lang="en-GB"/>
           </a:p>
@@ -5110,7 +5110,7 @@
           <a:p>
             <a:fld id="{E11858CF-6056-43B6-9057-C3E571ECFE2F}" type="datetimeFigureOut">
               <a:rPr lang="en-GB" smtClean="0"/>
-              <a:t>25/01/2022</a:t>
+              <a:t>29/04/2025</a:t>
             </a:fld>
             <a:endParaRPr lang="en-GB"/>
           </a:p>
@@ -6778,51 +6778,6 @@
           <a:chExt cx="0" cy="0"/>
         </a:xfrm>
       </p:grpSpPr>
-      <p:pic>
-        <p:nvPicPr>
-          <p:cNvPr id="1026" name="Picture 2">
-            <a:extLst>
-              <a:ext uri="{FF2B5EF4-FFF2-40B4-BE49-F238E27FC236}">
-                <a16:creationId xmlns:a16="http://schemas.microsoft.com/office/drawing/2014/main" id="{08209E48-140E-4173-A719-843105DCF0D6}"/>
-              </a:ext>
-            </a:extLst>
-          </p:cNvPr>
-          <p:cNvPicPr>
-            <a:picLocks noChangeAspect="1" noChangeArrowheads="1"/>
-          </p:cNvPicPr>
-          <p:nvPr/>
-        </p:nvPicPr>
-        <p:blipFill rotWithShape="1">
-          <a:blip r:embed="rId2">
-            <a:extLst>
-              <a:ext uri="{28A0092B-C50C-407E-A947-70E740481C1C}">
-                <a14:useLocalDpi xmlns:a14="http://schemas.microsoft.com/office/drawing/2010/main" val="0"/>
-              </a:ext>
-            </a:extLst>
-          </a:blip>
-          <a:srcRect t="9199"/>
-          <a:stretch/>
-        </p:blipFill>
-        <p:spPr bwMode="auto">
-          <a:xfrm>
-            <a:off x="5913800" y="2258008"/>
-            <a:ext cx="6149567" cy="4599992"/>
-          </a:xfrm>
-          <a:prstGeom prst="rect">
-            <a:avLst/>
-          </a:prstGeom>
-          <a:noFill/>
-          <a:extLst>
-            <a:ext uri="{909E8E84-426E-40DD-AFC4-6F175D3DCCD1}">
-              <a14:hiddenFill xmlns:a14="http://schemas.microsoft.com/office/drawing/2010/main">
-                <a:solidFill>
-                  <a:srgbClr val="FFFFFF"/>
-                </a:solidFill>
-              </a14:hiddenFill>
-            </a:ext>
-          </a:extLst>
-        </p:spPr>
-      </p:pic>
       <p:sp>
         <p:nvSpPr>
           <p:cNvPr id="2" name="Title 1">
@@ -6876,7 +6831,7 @@
           </p:nvPr>
         </p:nvPicPr>
         <p:blipFill rotWithShape="1">
-          <a:blip r:embed="rId3">
+          <a:blip r:embed="rId2">
             <a:extLst>
               <a:ext uri="{28A0092B-C50C-407E-A947-70E740481C1C}">
                 <a14:useLocalDpi xmlns:a14="http://schemas.microsoft.com/office/drawing/2010/main" val="0"/>
@@ -7029,6 +6984,83 @@
             <a:r>
               <a:rPr lang="en-GB" dirty="0"/>
               <a:t>, as described in the following figure, marked with blue colour.</a:t>
+            </a:r>
+          </a:p>
+        </p:txBody>
+      </p:sp>
+      <p:pic>
+        <p:nvPicPr>
+          <p:cNvPr id="4" name="Picture 3">
+            <a:extLst>
+              <a:ext uri="{FF2B5EF4-FFF2-40B4-BE49-F238E27FC236}">
+                <a16:creationId xmlns:a16="http://schemas.microsoft.com/office/drawing/2014/main" id="{1B34BBF5-6EBA-C367-802E-0D0818CC199E}"/>
+              </a:ext>
+            </a:extLst>
+          </p:cNvPr>
+          <p:cNvPicPr>
+            <a:picLocks noChangeAspect="1"/>
+          </p:cNvPicPr>
+          <p:nvPr/>
+        </p:nvPicPr>
+        <p:blipFill>
+          <a:blip r:embed="rId3">
+            <a:extLst>
+              <a:ext uri="{28A0092B-C50C-407E-A947-70E740481C1C}">
+                <a14:useLocalDpi xmlns:a14="http://schemas.microsoft.com/office/drawing/2010/main" val="0"/>
+              </a:ext>
+            </a:extLst>
+          </a:blip>
+          <a:stretch>
+            <a:fillRect/>
+          </a:stretch>
+        </p:blipFill>
+        <p:spPr>
+          <a:xfrm>
+            <a:off x="6745208" y="2387399"/>
+            <a:ext cx="5191894" cy="4328160"/>
+          </a:xfrm>
+          <a:prstGeom prst="rect">
+            <a:avLst/>
+          </a:prstGeom>
+        </p:spPr>
+      </p:pic>
+      <p:sp>
+        <p:nvSpPr>
+          <p:cNvPr id="6" name="Rectangle 5">
+            <a:extLst>
+              <a:ext uri="{FF2B5EF4-FFF2-40B4-BE49-F238E27FC236}">
+                <a16:creationId xmlns:a16="http://schemas.microsoft.com/office/drawing/2014/main" id="{FD4A2CCD-B0CD-C615-BFF7-EFC69424F0E9}"/>
+              </a:ext>
+            </a:extLst>
+          </p:cNvPr>
+          <p:cNvSpPr/>
+          <p:nvPr/>
+        </p:nvSpPr>
+        <p:spPr>
+          <a:xfrm>
+            <a:off x="11299402" y="6592448"/>
+            <a:ext cx="809837" cy="246221"/>
+          </a:xfrm>
+          <a:prstGeom prst="rect">
+            <a:avLst/>
+          </a:prstGeom>
+          <a:noFill/>
+        </p:spPr>
+        <p:txBody>
+          <a:bodyPr wrap="none" lIns="91440" tIns="45720" rIns="91440" bIns="45720">
+            <a:spAutoFit/>
+          </a:bodyPr>
+          <a:lstStyle/>
+          <a:p>
+            <a:pPr algn="ctr"/>
+            <a:r>
+              <a:rPr lang="en-US" sz="1000" b="0" cap="none" spc="0" dirty="0">
+                <a:ln w="0"/>
+                <a:solidFill>
+                  <a:srgbClr val="FF0000"/>
+                </a:solidFill>
+              </a:rPr>
+              <a:t>2025/04/29</a:t>
             </a:r>
           </a:p>
         </p:txBody>
@@ -8966,8 +8998,23 @@
                 <a:effectLst/>
                 <a:latin typeface="Courier New" panose="02070309020205020404" pitchFamily="49" charset="0"/>
               </a:rPr>
-              <a:t>Test Accuracy: 20.42% </a:t>
-            </a:r>
+              <a:t>Test Accuracy:</a:t>
+            </a:r>
+            <a:r>
+              <a:rPr lang="en-US" sz="2200" b="1" dirty="0">
+                <a:solidFill>
+                  <a:srgbClr val="FF0000"/>
+                </a:solidFill>
+                <a:latin typeface="Courier New" panose="02070309020205020404" pitchFamily="49" charset="0"/>
+              </a:rPr>
+              <a:t>20.759%</a:t>
+            </a:r>
+            <a:endParaRPr lang="en-GB" sz="2200" b="1" dirty="0">
+              <a:solidFill>
+                <a:srgbClr val="FF0000"/>
+              </a:solidFill>
+              <a:latin typeface="Courier New" panose="02070309020205020404" pitchFamily="49" charset="0"/>
+            </a:endParaRPr>
           </a:p>
           <a:p>
             <a:pPr marL="0" marR="0" lvl="0" indent="0" defTabSz="914400" rtl="0" eaLnBrk="0" fontAlgn="base" latinLnBrk="0" hangingPunct="0">
@@ -8998,10 +9045,10 @@
       </p:sp>
       <p:pic>
         <p:nvPicPr>
-          <p:cNvPr id="4" name="Picture 3">
-            <a:extLst>
-              <a:ext uri="{FF2B5EF4-FFF2-40B4-BE49-F238E27FC236}">
-                <a16:creationId xmlns:a16="http://schemas.microsoft.com/office/drawing/2014/main" id="{C993653C-AD10-40A9-9E93-9B6A556009B0}"/>
+          <p:cNvPr id="6" name="Picture 5">
+            <a:extLst>
+              <a:ext uri="{FF2B5EF4-FFF2-40B4-BE49-F238E27FC236}">
+                <a16:creationId xmlns:a16="http://schemas.microsoft.com/office/drawing/2014/main" id="{7B2D489A-23A4-E714-3A2D-18BA4F7D53FF}"/>
               </a:ext>
             </a:extLst>
           </p:cNvPr>
@@ -9011,15 +9058,21 @@
           <p:nvPr/>
         </p:nvPicPr>
         <p:blipFill>
-          <a:blip r:embed="rId2"/>
+          <a:blip r:embed="rId2">
+            <a:extLst>
+              <a:ext uri="{28A0092B-C50C-407E-A947-70E740481C1C}">
+                <a14:useLocalDpi xmlns:a14="http://schemas.microsoft.com/office/drawing/2010/main" val="0"/>
+              </a:ext>
+            </a:extLst>
+          </a:blip>
           <a:stretch>
             <a:fillRect/>
           </a:stretch>
         </p:blipFill>
         <p:spPr>
           <a:xfrm>
-            <a:off x="580370" y="2569464"/>
-            <a:ext cx="5039600" cy="3831336"/>
+            <a:off x="503924" y="2523861"/>
+            <a:ext cx="5129019" cy="4009410"/>
           </a:xfrm>
           <a:prstGeom prst="rect">
             <a:avLst/>
@@ -9028,10 +9081,10 @@
       </p:pic>
       <p:pic>
         <p:nvPicPr>
-          <p:cNvPr id="2" name="Picture 1">
-            <a:extLst>
-              <a:ext uri="{FF2B5EF4-FFF2-40B4-BE49-F238E27FC236}">
-                <a16:creationId xmlns:a16="http://schemas.microsoft.com/office/drawing/2014/main" id="{131A1C1B-64CD-4ABB-844C-D80375BF9B24}"/>
+          <p:cNvPr id="8" name="Picture 7">
+            <a:extLst>
+              <a:ext uri="{FF2B5EF4-FFF2-40B4-BE49-F238E27FC236}">
+                <a16:creationId xmlns:a16="http://schemas.microsoft.com/office/drawing/2014/main" id="{9695602F-681C-8671-0183-1F73323925F4}"/>
               </a:ext>
             </a:extLst>
           </p:cNvPr>
@@ -9041,21 +9094,150 @@
           <p:nvPr/>
         </p:nvPicPr>
         <p:blipFill>
-          <a:blip r:embed="rId3"/>
+          <a:blip r:embed="rId3">
+            <a:extLst>
+              <a:ext uri="{28A0092B-C50C-407E-A947-70E740481C1C}">
+                <a14:useLocalDpi xmlns:a14="http://schemas.microsoft.com/office/drawing/2010/main" val="0"/>
+              </a:ext>
+            </a:extLst>
+          </a:blip>
           <a:stretch>
             <a:fillRect/>
           </a:stretch>
         </p:blipFill>
         <p:spPr>
           <a:xfrm>
-            <a:off x="5837472" y="2569464"/>
-            <a:ext cx="5774158" cy="4094939"/>
+            <a:off x="6463786" y="2448302"/>
+            <a:ext cx="5340107" cy="4160528"/>
           </a:xfrm>
           <a:prstGeom prst="rect">
             <a:avLst/>
           </a:prstGeom>
         </p:spPr>
       </p:pic>
+      <p:sp>
+        <p:nvSpPr>
+          <p:cNvPr id="9" name="Rectangle 8">
+            <a:extLst>
+              <a:ext uri="{FF2B5EF4-FFF2-40B4-BE49-F238E27FC236}">
+                <a16:creationId xmlns:a16="http://schemas.microsoft.com/office/drawing/2014/main" id="{F9B292E4-AD06-D2A8-2E7C-68481647B09A}"/>
+              </a:ext>
+            </a:extLst>
+          </p:cNvPr>
+          <p:cNvSpPr/>
+          <p:nvPr/>
+        </p:nvSpPr>
+        <p:spPr>
+          <a:xfrm>
+            <a:off x="4834592" y="6410160"/>
+            <a:ext cx="809837" cy="246221"/>
+          </a:xfrm>
+          <a:prstGeom prst="rect">
+            <a:avLst/>
+          </a:prstGeom>
+          <a:noFill/>
+        </p:spPr>
+        <p:txBody>
+          <a:bodyPr wrap="none" lIns="91440" tIns="45720" rIns="91440" bIns="45720">
+            <a:spAutoFit/>
+          </a:bodyPr>
+          <a:lstStyle/>
+          <a:p>
+            <a:pPr algn="ctr"/>
+            <a:r>
+              <a:rPr lang="en-US" sz="1000" b="0" cap="none" spc="0" dirty="0">
+                <a:ln w="0"/>
+                <a:solidFill>
+                  <a:srgbClr val="FF0000"/>
+                </a:solidFill>
+              </a:rPr>
+              <a:t>2025/04/29</a:t>
+            </a:r>
+          </a:p>
+        </p:txBody>
+      </p:sp>
+      <p:sp>
+        <p:nvSpPr>
+          <p:cNvPr id="10" name="Rectangle 9">
+            <a:extLst>
+              <a:ext uri="{FF2B5EF4-FFF2-40B4-BE49-F238E27FC236}">
+                <a16:creationId xmlns:a16="http://schemas.microsoft.com/office/drawing/2014/main" id="{BB8071E6-9473-E5B1-7ED1-EDB51919D27A}"/>
+              </a:ext>
+            </a:extLst>
+          </p:cNvPr>
+          <p:cNvSpPr/>
+          <p:nvPr/>
+        </p:nvSpPr>
+        <p:spPr>
+          <a:xfrm>
+            <a:off x="10994056" y="6485719"/>
+            <a:ext cx="809837" cy="246221"/>
+          </a:xfrm>
+          <a:prstGeom prst="rect">
+            <a:avLst/>
+          </a:prstGeom>
+          <a:noFill/>
+        </p:spPr>
+        <p:txBody>
+          <a:bodyPr wrap="none" lIns="91440" tIns="45720" rIns="91440" bIns="45720">
+            <a:spAutoFit/>
+          </a:bodyPr>
+          <a:lstStyle/>
+          <a:p>
+            <a:pPr algn="ctr"/>
+            <a:r>
+              <a:rPr lang="en-US" sz="1000" b="0" cap="none" spc="0" dirty="0">
+                <a:ln w="0"/>
+                <a:solidFill>
+                  <a:srgbClr val="FF0000"/>
+                </a:solidFill>
+              </a:rPr>
+              <a:t>2025/04/29</a:t>
+            </a:r>
+          </a:p>
+        </p:txBody>
+      </p:sp>
+      <p:sp>
+        <p:nvSpPr>
+          <p:cNvPr id="13" name="Rectangle 12">
+            <a:extLst>
+              <a:ext uri="{FF2B5EF4-FFF2-40B4-BE49-F238E27FC236}">
+                <a16:creationId xmlns:a16="http://schemas.microsoft.com/office/drawing/2014/main" id="{4282F7DA-5F63-58AC-3694-BF1FC789A0F8}"/>
+              </a:ext>
+            </a:extLst>
+          </p:cNvPr>
+          <p:cNvSpPr/>
+          <p:nvPr/>
+        </p:nvSpPr>
+        <p:spPr>
+          <a:xfrm>
+            <a:off x="8940436" y="951722"/>
+            <a:ext cx="809837" cy="246221"/>
+          </a:xfrm>
+          <a:prstGeom prst="rect">
+            <a:avLst/>
+          </a:prstGeom>
+          <a:noFill/>
+        </p:spPr>
+        <p:txBody>
+          <a:bodyPr wrap="none" lIns="91440" tIns="45720" rIns="91440" bIns="45720">
+            <a:spAutoFit/>
+          </a:bodyPr>
+          <a:lstStyle/>
+          <a:p>
+            <a:pPr algn="ctr"/>
+            <a:r>
+              <a:rPr lang="en-US" sz="1000" b="0" cap="none" spc="0" dirty="0">
+                <a:ln w="0"/>
+                <a:solidFill>
+                  <a:srgbClr val="FF0000"/>
+                </a:solidFill>
+              </a:rPr>
+              <a:t>2025/04/29</a:t>
+            </a:r>
+          </a:p>
+        </p:txBody>
+      </p:sp>
     </p:spTree>
     <p:extLst>
       <p:ext uri="{BB962C8B-B14F-4D97-AF65-F5344CB8AC3E}">

</xml_diff>

<commit_message>
update: update image and slide
</commit_message>
<xml_diff>
--- a/slides.pptx
+++ b/slides.pptx
@@ -136,123 +136,6 @@
 <file path=ppt/changesInfos/changesInfo1.xml><?xml version="1.0" encoding="utf-8"?>
 <pc:chgInfo xmlns:a="http://schemas.openxmlformats.org/drawingml/2006/main" xmlns:r="http://schemas.openxmlformats.org/officeDocument/2006/relationships" xmlns:ac="http://schemas.microsoft.com/office/drawing/2013/main/command" xmlns:pc="http://schemas.microsoft.com/office/powerpoint/2013/main/command">
   <pc:docChgLst>
-    <pc:chgData name="Nitzan" userId="c6f4b9ed-2c00-430b-ae2d-675e9e5eba4f" providerId="ADAL" clId="{7E7D16A4-A1AB-40AA-BA80-DFB3D6FA62E4}"/>
-    <pc:docChg chg="custSel addSld modSld sldOrd">
-      <pc:chgData name="Nitzan" userId="c6f4b9ed-2c00-430b-ae2d-675e9e5eba4f" providerId="ADAL" clId="{7E7D16A4-A1AB-40AA-BA80-DFB3D6FA62E4}" dt="2022-01-11T09:34:38.830" v="105" actId="1076"/>
-      <pc:docMkLst>
-        <pc:docMk/>
-      </pc:docMkLst>
-      <pc:sldChg chg="modSp mod">
-        <pc:chgData name="Nitzan" userId="c6f4b9ed-2c00-430b-ae2d-675e9e5eba4f" providerId="ADAL" clId="{7E7D16A4-A1AB-40AA-BA80-DFB3D6FA62E4}" dt="2022-01-11T09:30:27.232" v="21" actId="20577"/>
-        <pc:sldMkLst>
-          <pc:docMk/>
-          <pc:sldMk cId="2727192941" sldId="257"/>
-        </pc:sldMkLst>
-        <pc:spChg chg="mod">
-          <ac:chgData name="Nitzan" userId="c6f4b9ed-2c00-430b-ae2d-675e9e5eba4f" providerId="ADAL" clId="{7E7D16A4-A1AB-40AA-BA80-DFB3D6FA62E4}" dt="2022-01-11T09:30:27.232" v="21" actId="20577"/>
-          <ac:spMkLst>
-            <pc:docMk/>
-            <pc:sldMk cId="2727192941" sldId="257"/>
-            <ac:spMk id="2" creationId="{271C905E-90FE-4FEA-A334-AFB4B7F4D610}"/>
-          </ac:spMkLst>
-        </pc:spChg>
-      </pc:sldChg>
-      <pc:sldChg chg="addSp delSp modSp add mod">
-        <pc:chgData name="Nitzan" userId="c6f4b9ed-2c00-430b-ae2d-675e9e5eba4f" providerId="ADAL" clId="{7E7D16A4-A1AB-40AA-BA80-DFB3D6FA62E4}" dt="2022-01-11T09:33:40.380" v="73" actId="1076"/>
-        <pc:sldMkLst>
-          <pc:docMk/>
-          <pc:sldMk cId="3484230388" sldId="258"/>
-        </pc:sldMkLst>
-        <pc:spChg chg="mod">
-          <ac:chgData name="Nitzan" userId="c6f4b9ed-2c00-430b-ae2d-675e9e5eba4f" providerId="ADAL" clId="{7E7D16A4-A1AB-40AA-BA80-DFB3D6FA62E4}" dt="2022-01-11T09:31:08.304" v="60" actId="1076"/>
-          <ac:spMkLst>
-            <pc:docMk/>
-            <pc:sldMk cId="3484230388" sldId="258"/>
-            <ac:spMk id="2" creationId="{271C905E-90FE-4FEA-A334-AFB4B7F4D610}"/>
-          </ac:spMkLst>
-        </pc:spChg>
-        <pc:spChg chg="mod">
-          <ac:chgData name="Nitzan" userId="c6f4b9ed-2c00-430b-ae2d-675e9e5eba4f" providerId="ADAL" clId="{7E7D16A4-A1AB-40AA-BA80-DFB3D6FA62E4}" dt="2022-01-11T09:32:48.520" v="63" actId="313"/>
-          <ac:spMkLst>
-            <pc:docMk/>
-            <pc:sldMk cId="3484230388" sldId="258"/>
-            <ac:spMk id="4" creationId="{11254D5E-1A37-49FD-82D3-351F01110A39}"/>
-          </ac:spMkLst>
-        </pc:spChg>
-        <pc:picChg chg="del">
-          <ac:chgData name="Nitzan" userId="c6f4b9ed-2c00-430b-ae2d-675e9e5eba4f" providerId="ADAL" clId="{7E7D16A4-A1AB-40AA-BA80-DFB3D6FA62E4}" dt="2022-01-11T09:32:51.995" v="64" actId="478"/>
-          <ac:picMkLst>
-            <pc:docMk/>
-            <pc:sldMk cId="3484230388" sldId="258"/>
-            <ac:picMk id="1026" creationId="{D0268B57-6DDE-43B8-88FA-5CAA527D4604}"/>
-          </ac:picMkLst>
-        </pc:picChg>
-        <pc:picChg chg="add del mod">
-          <ac:chgData name="Nitzan" userId="c6f4b9ed-2c00-430b-ae2d-675e9e5eba4f" providerId="ADAL" clId="{7E7D16A4-A1AB-40AA-BA80-DFB3D6FA62E4}" dt="2022-01-11T09:33:40.380" v="73" actId="1076"/>
-          <ac:picMkLst>
-            <pc:docMk/>
-            <pc:sldMk cId="3484230388" sldId="258"/>
-            <ac:picMk id="2050" creationId="{5630289D-F068-46E0-82A3-87CFB5DD7AA3}"/>
-          </ac:picMkLst>
-        </pc:picChg>
-      </pc:sldChg>
-      <pc:sldChg chg="delSp modSp new mod">
-        <pc:chgData name="Nitzan" userId="c6f4b9ed-2c00-430b-ae2d-675e9e5eba4f" providerId="ADAL" clId="{7E7D16A4-A1AB-40AA-BA80-DFB3D6FA62E4}" dt="2022-01-11T09:33:58.140" v="87" actId="478"/>
-        <pc:sldMkLst>
-          <pc:docMk/>
-          <pc:sldMk cId="3982802005" sldId="259"/>
-        </pc:sldMkLst>
-        <pc:spChg chg="mod">
-          <ac:chgData name="Nitzan" userId="c6f4b9ed-2c00-430b-ae2d-675e9e5eba4f" providerId="ADAL" clId="{7E7D16A4-A1AB-40AA-BA80-DFB3D6FA62E4}" dt="2022-01-11T09:33:55.336" v="86" actId="20577"/>
-          <ac:spMkLst>
-            <pc:docMk/>
-            <pc:sldMk cId="3982802005" sldId="259"/>
-            <ac:spMk id="2" creationId="{730C987A-8020-47EF-9907-29D3DCFE70E7}"/>
-          </ac:spMkLst>
-        </pc:spChg>
-        <pc:spChg chg="del">
-          <ac:chgData name="Nitzan" userId="c6f4b9ed-2c00-430b-ae2d-675e9e5eba4f" providerId="ADAL" clId="{7E7D16A4-A1AB-40AA-BA80-DFB3D6FA62E4}" dt="2022-01-11T09:33:58.140" v="87" actId="478"/>
-          <ac:spMkLst>
-            <pc:docMk/>
-            <pc:sldMk cId="3982802005" sldId="259"/>
-            <ac:spMk id="3" creationId="{D6A520A7-1485-4AEB-8B47-085202132B59}"/>
-          </ac:spMkLst>
-        </pc:spChg>
-      </pc:sldChg>
-      <pc:sldChg chg="addSp delSp modSp new mod ord">
-        <pc:chgData name="Nitzan" userId="c6f4b9ed-2c00-430b-ae2d-675e9e5eba4f" providerId="ADAL" clId="{7E7D16A4-A1AB-40AA-BA80-DFB3D6FA62E4}" dt="2022-01-11T09:34:38.830" v="105" actId="1076"/>
-        <pc:sldMkLst>
-          <pc:docMk/>
-          <pc:sldMk cId="4039449901" sldId="260"/>
-        </pc:sldMkLst>
-        <pc:spChg chg="mod">
-          <ac:chgData name="Nitzan" userId="c6f4b9ed-2c00-430b-ae2d-675e9e5eba4f" providerId="ADAL" clId="{7E7D16A4-A1AB-40AA-BA80-DFB3D6FA62E4}" dt="2022-01-11T09:34:34.078" v="102" actId="20577"/>
-          <ac:spMkLst>
-            <pc:docMk/>
-            <pc:sldMk cId="4039449901" sldId="260"/>
-            <ac:spMk id="2" creationId="{18FAE654-BFBD-4E60-8E22-B0A1141C6815}"/>
-          </ac:spMkLst>
-        </pc:spChg>
-        <pc:spChg chg="del">
-          <ac:chgData name="Nitzan" userId="c6f4b9ed-2c00-430b-ae2d-675e9e5eba4f" providerId="ADAL" clId="{7E7D16A4-A1AB-40AA-BA80-DFB3D6FA62E4}" dt="2022-01-11T09:34:37.156" v="103" actId="478"/>
-          <ac:spMkLst>
-            <pc:docMk/>
-            <pc:sldMk cId="4039449901" sldId="260"/>
-            <ac:spMk id="3" creationId="{106A01EB-CC09-4207-8F92-35E4300337D1}"/>
-          </ac:spMkLst>
-        </pc:spChg>
-        <pc:picChg chg="add mod">
-          <ac:chgData name="Nitzan" userId="c6f4b9ed-2c00-430b-ae2d-675e9e5eba4f" providerId="ADAL" clId="{7E7D16A4-A1AB-40AA-BA80-DFB3D6FA62E4}" dt="2022-01-11T09:34:38.830" v="105" actId="1076"/>
-          <ac:picMkLst>
-            <pc:docMk/>
-            <pc:sldMk cId="4039449901" sldId="260"/>
-            <ac:picMk id="5" creationId="{DFCCD338-E36A-447D-B109-D5C9245D52EC}"/>
-          </ac:picMkLst>
-        </pc:picChg>
-      </pc:sldChg>
-    </pc:docChg>
-  </pc:docChgLst>
-  <pc:docChgLst>
     <pc:chgData name="Nitzan" userId="c6f4b9ed-2c00-430b-ae2d-675e9e5eba4f" providerId="ADAL" clId="{28177BFD-E31E-4889-94FB-C3F3258A7F51}"/>
     <pc:docChg chg="undo custSel addSld delSld modSld sldOrd">
       <pc:chgData name="Nitzan" userId="c6f4b9ed-2c00-430b-ae2d-675e9e5eba4f" providerId="ADAL" clId="{28177BFD-E31E-4889-94FB-C3F3258A7F51}" dt="2022-01-25T12:16:02.803" v="1887" actId="1076"/>
@@ -1706,6 +1589,123 @@
             <ac:inkMk id="75" creationId="{2CEF958A-17D6-425F-86F5-FA17EAB2E469}"/>
           </ac:inkMkLst>
         </pc:inkChg>
+      </pc:sldChg>
+    </pc:docChg>
+  </pc:docChgLst>
+  <pc:docChgLst>
+    <pc:chgData name="Nitzan" userId="c6f4b9ed-2c00-430b-ae2d-675e9e5eba4f" providerId="ADAL" clId="{7E7D16A4-A1AB-40AA-BA80-DFB3D6FA62E4}"/>
+    <pc:docChg chg="custSel addSld modSld sldOrd">
+      <pc:chgData name="Nitzan" userId="c6f4b9ed-2c00-430b-ae2d-675e9e5eba4f" providerId="ADAL" clId="{7E7D16A4-A1AB-40AA-BA80-DFB3D6FA62E4}" dt="2022-01-11T09:34:38.830" v="105" actId="1076"/>
+      <pc:docMkLst>
+        <pc:docMk/>
+      </pc:docMkLst>
+      <pc:sldChg chg="modSp mod">
+        <pc:chgData name="Nitzan" userId="c6f4b9ed-2c00-430b-ae2d-675e9e5eba4f" providerId="ADAL" clId="{7E7D16A4-A1AB-40AA-BA80-DFB3D6FA62E4}" dt="2022-01-11T09:30:27.232" v="21" actId="20577"/>
+        <pc:sldMkLst>
+          <pc:docMk/>
+          <pc:sldMk cId="2727192941" sldId="257"/>
+        </pc:sldMkLst>
+        <pc:spChg chg="mod">
+          <ac:chgData name="Nitzan" userId="c6f4b9ed-2c00-430b-ae2d-675e9e5eba4f" providerId="ADAL" clId="{7E7D16A4-A1AB-40AA-BA80-DFB3D6FA62E4}" dt="2022-01-11T09:30:27.232" v="21" actId="20577"/>
+          <ac:spMkLst>
+            <pc:docMk/>
+            <pc:sldMk cId="2727192941" sldId="257"/>
+            <ac:spMk id="2" creationId="{271C905E-90FE-4FEA-A334-AFB4B7F4D610}"/>
+          </ac:spMkLst>
+        </pc:spChg>
+      </pc:sldChg>
+      <pc:sldChg chg="addSp delSp modSp add mod">
+        <pc:chgData name="Nitzan" userId="c6f4b9ed-2c00-430b-ae2d-675e9e5eba4f" providerId="ADAL" clId="{7E7D16A4-A1AB-40AA-BA80-DFB3D6FA62E4}" dt="2022-01-11T09:33:40.380" v="73" actId="1076"/>
+        <pc:sldMkLst>
+          <pc:docMk/>
+          <pc:sldMk cId="3484230388" sldId="258"/>
+        </pc:sldMkLst>
+        <pc:spChg chg="mod">
+          <ac:chgData name="Nitzan" userId="c6f4b9ed-2c00-430b-ae2d-675e9e5eba4f" providerId="ADAL" clId="{7E7D16A4-A1AB-40AA-BA80-DFB3D6FA62E4}" dt="2022-01-11T09:31:08.304" v="60" actId="1076"/>
+          <ac:spMkLst>
+            <pc:docMk/>
+            <pc:sldMk cId="3484230388" sldId="258"/>
+            <ac:spMk id="2" creationId="{271C905E-90FE-4FEA-A334-AFB4B7F4D610}"/>
+          </ac:spMkLst>
+        </pc:spChg>
+        <pc:spChg chg="mod">
+          <ac:chgData name="Nitzan" userId="c6f4b9ed-2c00-430b-ae2d-675e9e5eba4f" providerId="ADAL" clId="{7E7D16A4-A1AB-40AA-BA80-DFB3D6FA62E4}" dt="2022-01-11T09:32:48.520" v="63" actId="313"/>
+          <ac:spMkLst>
+            <pc:docMk/>
+            <pc:sldMk cId="3484230388" sldId="258"/>
+            <ac:spMk id="4" creationId="{11254D5E-1A37-49FD-82D3-351F01110A39}"/>
+          </ac:spMkLst>
+        </pc:spChg>
+        <pc:picChg chg="del">
+          <ac:chgData name="Nitzan" userId="c6f4b9ed-2c00-430b-ae2d-675e9e5eba4f" providerId="ADAL" clId="{7E7D16A4-A1AB-40AA-BA80-DFB3D6FA62E4}" dt="2022-01-11T09:32:51.995" v="64" actId="478"/>
+          <ac:picMkLst>
+            <pc:docMk/>
+            <pc:sldMk cId="3484230388" sldId="258"/>
+            <ac:picMk id="1026" creationId="{D0268B57-6DDE-43B8-88FA-5CAA527D4604}"/>
+          </ac:picMkLst>
+        </pc:picChg>
+        <pc:picChg chg="add del mod">
+          <ac:chgData name="Nitzan" userId="c6f4b9ed-2c00-430b-ae2d-675e9e5eba4f" providerId="ADAL" clId="{7E7D16A4-A1AB-40AA-BA80-DFB3D6FA62E4}" dt="2022-01-11T09:33:40.380" v="73" actId="1076"/>
+          <ac:picMkLst>
+            <pc:docMk/>
+            <pc:sldMk cId="3484230388" sldId="258"/>
+            <ac:picMk id="2050" creationId="{5630289D-F068-46E0-82A3-87CFB5DD7AA3}"/>
+          </ac:picMkLst>
+        </pc:picChg>
+      </pc:sldChg>
+      <pc:sldChg chg="delSp modSp new mod">
+        <pc:chgData name="Nitzan" userId="c6f4b9ed-2c00-430b-ae2d-675e9e5eba4f" providerId="ADAL" clId="{7E7D16A4-A1AB-40AA-BA80-DFB3D6FA62E4}" dt="2022-01-11T09:33:58.140" v="87" actId="478"/>
+        <pc:sldMkLst>
+          <pc:docMk/>
+          <pc:sldMk cId="3982802005" sldId="259"/>
+        </pc:sldMkLst>
+        <pc:spChg chg="mod">
+          <ac:chgData name="Nitzan" userId="c6f4b9ed-2c00-430b-ae2d-675e9e5eba4f" providerId="ADAL" clId="{7E7D16A4-A1AB-40AA-BA80-DFB3D6FA62E4}" dt="2022-01-11T09:33:55.336" v="86" actId="20577"/>
+          <ac:spMkLst>
+            <pc:docMk/>
+            <pc:sldMk cId="3982802005" sldId="259"/>
+            <ac:spMk id="2" creationId="{730C987A-8020-47EF-9907-29D3DCFE70E7}"/>
+          </ac:spMkLst>
+        </pc:spChg>
+        <pc:spChg chg="del">
+          <ac:chgData name="Nitzan" userId="c6f4b9ed-2c00-430b-ae2d-675e9e5eba4f" providerId="ADAL" clId="{7E7D16A4-A1AB-40AA-BA80-DFB3D6FA62E4}" dt="2022-01-11T09:33:58.140" v="87" actId="478"/>
+          <ac:spMkLst>
+            <pc:docMk/>
+            <pc:sldMk cId="3982802005" sldId="259"/>
+            <ac:spMk id="3" creationId="{D6A520A7-1485-4AEB-8B47-085202132B59}"/>
+          </ac:spMkLst>
+        </pc:spChg>
+      </pc:sldChg>
+      <pc:sldChg chg="addSp delSp modSp new mod ord">
+        <pc:chgData name="Nitzan" userId="c6f4b9ed-2c00-430b-ae2d-675e9e5eba4f" providerId="ADAL" clId="{7E7D16A4-A1AB-40AA-BA80-DFB3D6FA62E4}" dt="2022-01-11T09:34:38.830" v="105" actId="1076"/>
+        <pc:sldMkLst>
+          <pc:docMk/>
+          <pc:sldMk cId="4039449901" sldId="260"/>
+        </pc:sldMkLst>
+        <pc:spChg chg="mod">
+          <ac:chgData name="Nitzan" userId="c6f4b9ed-2c00-430b-ae2d-675e9e5eba4f" providerId="ADAL" clId="{7E7D16A4-A1AB-40AA-BA80-DFB3D6FA62E4}" dt="2022-01-11T09:34:34.078" v="102" actId="20577"/>
+          <ac:spMkLst>
+            <pc:docMk/>
+            <pc:sldMk cId="4039449901" sldId="260"/>
+            <ac:spMk id="2" creationId="{18FAE654-BFBD-4E60-8E22-B0A1141C6815}"/>
+          </ac:spMkLst>
+        </pc:spChg>
+        <pc:spChg chg="del">
+          <ac:chgData name="Nitzan" userId="c6f4b9ed-2c00-430b-ae2d-675e9e5eba4f" providerId="ADAL" clId="{7E7D16A4-A1AB-40AA-BA80-DFB3D6FA62E4}" dt="2022-01-11T09:34:37.156" v="103" actId="478"/>
+          <ac:spMkLst>
+            <pc:docMk/>
+            <pc:sldMk cId="4039449901" sldId="260"/>
+            <ac:spMk id="3" creationId="{106A01EB-CC09-4207-8F92-35E4300337D1}"/>
+          </ac:spMkLst>
+        </pc:spChg>
+        <pc:picChg chg="add mod">
+          <ac:chgData name="Nitzan" userId="c6f4b9ed-2c00-430b-ae2d-675e9e5eba4f" providerId="ADAL" clId="{7E7D16A4-A1AB-40AA-BA80-DFB3D6FA62E4}" dt="2022-01-11T09:34:38.830" v="105" actId="1076"/>
+          <ac:picMkLst>
+            <pc:docMk/>
+            <pc:sldMk cId="4039449901" sldId="260"/>
+            <ac:picMk id="5" creationId="{DFCCD338-E36A-447D-B109-D5C9245D52EC}"/>
+          </ac:picMkLst>
+        </pc:picChg>
       </pc:sldChg>
     </pc:docChg>
   </pc:docChgLst>
@@ -1910,7 +1910,7 @@
           <a:p>
             <a:fld id="{27D8F877-061F-4F1B-ABEB-F2386F6B7DA6}" type="datetimeFigureOut">
               <a:rPr lang="en-GB" smtClean="0"/>
-              <a:t>25/01/2022</a:t>
+              <a:t>22/05/2025</a:t>
             </a:fld>
             <a:endParaRPr lang="en-GB"/>
           </a:p>
@@ -2441,7 +2441,7 @@
           <a:p>
             <a:fld id="{E11858CF-6056-43B6-9057-C3E571ECFE2F}" type="datetimeFigureOut">
               <a:rPr lang="en-GB" smtClean="0"/>
-              <a:t>25/01/2022</a:t>
+              <a:t>22/05/2025</a:t>
             </a:fld>
             <a:endParaRPr lang="en-GB"/>
           </a:p>
@@ -2641,7 +2641,7 @@
           <a:p>
             <a:fld id="{E11858CF-6056-43B6-9057-C3E571ECFE2F}" type="datetimeFigureOut">
               <a:rPr lang="en-GB" smtClean="0"/>
-              <a:t>25/01/2022</a:t>
+              <a:t>22/05/2025</a:t>
             </a:fld>
             <a:endParaRPr lang="en-GB"/>
           </a:p>
@@ -2851,7 +2851,7 @@
           <a:p>
             <a:fld id="{E11858CF-6056-43B6-9057-C3E571ECFE2F}" type="datetimeFigureOut">
               <a:rPr lang="en-GB" smtClean="0"/>
-              <a:t>25/01/2022</a:t>
+              <a:t>22/05/2025</a:t>
             </a:fld>
             <a:endParaRPr lang="en-GB"/>
           </a:p>
@@ -3051,7 +3051,7 @@
           <a:p>
             <a:fld id="{E11858CF-6056-43B6-9057-C3E571ECFE2F}" type="datetimeFigureOut">
               <a:rPr lang="en-GB" smtClean="0"/>
-              <a:t>25/01/2022</a:t>
+              <a:t>22/05/2025</a:t>
             </a:fld>
             <a:endParaRPr lang="en-GB"/>
           </a:p>
@@ -3327,7 +3327,7 @@
           <a:p>
             <a:fld id="{E11858CF-6056-43B6-9057-C3E571ECFE2F}" type="datetimeFigureOut">
               <a:rPr lang="en-GB" smtClean="0"/>
-              <a:t>25/01/2022</a:t>
+              <a:t>22/05/2025</a:t>
             </a:fld>
             <a:endParaRPr lang="en-GB"/>
           </a:p>
@@ -3595,7 +3595,7 @@
           <a:p>
             <a:fld id="{E11858CF-6056-43B6-9057-C3E571ECFE2F}" type="datetimeFigureOut">
               <a:rPr lang="en-GB" smtClean="0"/>
-              <a:t>25/01/2022</a:t>
+              <a:t>22/05/2025</a:t>
             </a:fld>
             <a:endParaRPr lang="en-GB"/>
           </a:p>
@@ -4010,7 +4010,7 @@
           <a:p>
             <a:fld id="{E11858CF-6056-43B6-9057-C3E571ECFE2F}" type="datetimeFigureOut">
               <a:rPr lang="en-GB" smtClean="0"/>
-              <a:t>25/01/2022</a:t>
+              <a:t>22/05/2025</a:t>
             </a:fld>
             <a:endParaRPr lang="en-GB"/>
           </a:p>
@@ -4152,7 +4152,7 @@
           <a:p>
             <a:fld id="{E11858CF-6056-43B6-9057-C3E571ECFE2F}" type="datetimeFigureOut">
               <a:rPr lang="en-GB" smtClean="0"/>
-              <a:t>25/01/2022</a:t>
+              <a:t>22/05/2025</a:t>
             </a:fld>
             <a:endParaRPr lang="en-GB"/>
           </a:p>
@@ -4265,7 +4265,7 @@
           <a:p>
             <a:fld id="{E11858CF-6056-43B6-9057-C3E571ECFE2F}" type="datetimeFigureOut">
               <a:rPr lang="en-GB" smtClean="0"/>
-              <a:t>25/01/2022</a:t>
+              <a:t>22/05/2025</a:t>
             </a:fld>
             <a:endParaRPr lang="en-GB"/>
           </a:p>
@@ -4578,7 +4578,7 @@
           <a:p>
             <a:fld id="{E11858CF-6056-43B6-9057-C3E571ECFE2F}" type="datetimeFigureOut">
               <a:rPr lang="en-GB" smtClean="0"/>
-              <a:t>25/01/2022</a:t>
+              <a:t>22/05/2025</a:t>
             </a:fld>
             <a:endParaRPr lang="en-GB"/>
           </a:p>
@@ -4867,7 +4867,7 @@
           <a:p>
             <a:fld id="{E11858CF-6056-43B6-9057-C3E571ECFE2F}" type="datetimeFigureOut">
               <a:rPr lang="en-GB" smtClean="0"/>
-              <a:t>25/01/2022</a:t>
+              <a:t>22/05/2025</a:t>
             </a:fld>
             <a:endParaRPr lang="en-GB"/>
           </a:p>
@@ -5110,7 +5110,7 @@
           <a:p>
             <a:fld id="{E11858CF-6056-43B6-9057-C3E571ECFE2F}" type="datetimeFigureOut">
               <a:rPr lang="en-GB" smtClean="0"/>
-              <a:t>25/01/2022</a:t>
+              <a:t>22/05/2025</a:t>
             </a:fld>
             <a:endParaRPr lang="en-GB"/>
           </a:p>
@@ -8966,7 +8966,7 @@
                 <a:effectLst/>
                 <a:latin typeface="Courier New" panose="02070309020205020404" pitchFamily="49" charset="0"/>
               </a:rPr>
-              <a:t>Test Accuracy: 20.42% </a:t>
+              <a:t>Test Accuracy: 20.992% </a:t>
             </a:r>
           </a:p>
           <a:p>
@@ -8998,64 +8998,180 @@
       </p:sp>
       <p:pic>
         <p:nvPicPr>
-          <p:cNvPr id="4" name="Picture 3">
-            <a:extLst>
-              <a:ext uri="{FF2B5EF4-FFF2-40B4-BE49-F238E27FC236}">
-                <a16:creationId xmlns:a16="http://schemas.microsoft.com/office/drawing/2014/main" id="{C993653C-AD10-40A9-9E93-9B6A556009B0}"/>
+          <p:cNvPr id="1026" name="Picture 2">
+            <a:extLst>
+              <a:ext uri="{FF2B5EF4-FFF2-40B4-BE49-F238E27FC236}">
+                <a16:creationId xmlns:a16="http://schemas.microsoft.com/office/drawing/2014/main" id="{E388F571-A271-4E9C-FD92-A0651501A135}"/>
               </a:ext>
             </a:extLst>
           </p:cNvPr>
           <p:cNvPicPr>
-            <a:picLocks noChangeAspect="1"/>
+            <a:picLocks noChangeAspect="1" noChangeArrowheads="1"/>
           </p:cNvPicPr>
           <p:nvPr/>
         </p:nvPicPr>
         <p:blipFill>
-          <a:blip r:embed="rId2"/>
+          <a:blip r:embed="rId2">
+            <a:extLst>
+              <a:ext uri="{28A0092B-C50C-407E-A947-70E740481C1C}">
+                <a14:useLocalDpi xmlns:a14="http://schemas.microsoft.com/office/drawing/2010/main" val="0"/>
+              </a:ext>
+            </a:extLst>
+          </a:blip>
+          <a:srcRect/>
           <a:stretch>
             <a:fillRect/>
           </a:stretch>
         </p:blipFill>
-        <p:spPr>
+        <p:spPr bwMode="auto">
           <a:xfrm>
-            <a:off x="580370" y="2569464"/>
-            <a:ext cx="5039600" cy="3831336"/>
+            <a:off x="327025" y="2466551"/>
+            <a:ext cx="5248783" cy="4103031"/>
           </a:xfrm>
           <a:prstGeom prst="rect">
             <a:avLst/>
           </a:prstGeom>
+          <a:noFill/>
+          <a:extLst>
+            <a:ext uri="{909E8E84-426E-40DD-AFC4-6F175D3DCCD1}">
+              <a14:hiddenFill xmlns:a14="http://schemas.microsoft.com/office/drawing/2010/main">
+                <a:solidFill>
+                  <a:srgbClr val="FFFFFF"/>
+                </a:solidFill>
+              </a14:hiddenFill>
+            </a:ext>
+          </a:extLst>
         </p:spPr>
       </p:pic>
       <p:pic>
         <p:nvPicPr>
-          <p:cNvPr id="2" name="Picture 1">
-            <a:extLst>
-              <a:ext uri="{FF2B5EF4-FFF2-40B4-BE49-F238E27FC236}">
-                <a16:creationId xmlns:a16="http://schemas.microsoft.com/office/drawing/2014/main" id="{131A1C1B-64CD-4ABB-844C-D80375BF9B24}"/>
+          <p:cNvPr id="1028" name="Picture 4">
+            <a:extLst>
+              <a:ext uri="{FF2B5EF4-FFF2-40B4-BE49-F238E27FC236}">
+                <a16:creationId xmlns:a16="http://schemas.microsoft.com/office/drawing/2014/main" id="{0FAF1BFF-8A6E-EAC2-82AC-4908330ABA33}"/>
               </a:ext>
             </a:extLst>
           </p:cNvPr>
           <p:cNvPicPr>
-            <a:picLocks noChangeAspect="1"/>
+            <a:picLocks noChangeAspect="1" noChangeArrowheads="1"/>
           </p:cNvPicPr>
           <p:nvPr/>
         </p:nvPicPr>
         <p:blipFill>
-          <a:blip r:embed="rId3"/>
+          <a:blip r:embed="rId3">
+            <a:extLst>
+              <a:ext uri="{28A0092B-C50C-407E-A947-70E740481C1C}">
+                <a14:useLocalDpi xmlns:a14="http://schemas.microsoft.com/office/drawing/2010/main" val="0"/>
+              </a:ext>
+            </a:extLst>
+          </a:blip>
+          <a:srcRect/>
           <a:stretch>
             <a:fillRect/>
           </a:stretch>
         </p:blipFill>
-        <p:spPr>
+        <p:spPr bwMode="auto">
           <a:xfrm>
-            <a:off x="5837472" y="2569464"/>
-            <a:ext cx="5774158" cy="4094939"/>
+            <a:off x="6094476" y="2525324"/>
+            <a:ext cx="5115433" cy="3985483"/>
           </a:xfrm>
           <a:prstGeom prst="rect">
             <a:avLst/>
           </a:prstGeom>
+          <a:noFill/>
+          <a:extLst>
+            <a:ext uri="{909E8E84-426E-40DD-AFC4-6F175D3DCCD1}">
+              <a14:hiddenFill xmlns:a14="http://schemas.microsoft.com/office/drawing/2010/main">
+                <a:solidFill>
+                  <a:srgbClr val="FFFFFF"/>
+                </a:solidFill>
+              </a14:hiddenFill>
+            </a:ext>
+          </a:extLst>
         </p:spPr>
       </p:pic>
+      <p:sp>
+        <p:nvSpPr>
+          <p:cNvPr id="5" name="Rectangle 4">
+            <a:extLst>
+              <a:ext uri="{FF2B5EF4-FFF2-40B4-BE49-F238E27FC236}">
+                <a16:creationId xmlns:a16="http://schemas.microsoft.com/office/drawing/2014/main" id="{0DFEB4FA-B947-D202-E8F6-95B56D63FB52}"/>
+              </a:ext>
+            </a:extLst>
+          </p:cNvPr>
+          <p:cNvSpPr/>
+          <p:nvPr/>
+        </p:nvSpPr>
+        <p:spPr>
+          <a:xfrm>
+            <a:off x="5497914" y="6154579"/>
+            <a:ext cx="809837" cy="246221"/>
+          </a:xfrm>
+          <a:prstGeom prst="rect">
+            <a:avLst/>
+          </a:prstGeom>
+          <a:noFill/>
+        </p:spPr>
+        <p:txBody>
+          <a:bodyPr wrap="none" lIns="91440" tIns="45720" rIns="91440" bIns="45720">
+            <a:spAutoFit/>
+          </a:bodyPr>
+          <a:lstStyle/>
+          <a:p>
+            <a:pPr algn="ctr"/>
+            <a:r>
+              <a:rPr lang="en-US" sz="1000" b="0" cap="none" spc="0" dirty="0">
+                <a:ln w="0"/>
+                <a:solidFill>
+                  <a:srgbClr val="FF0000"/>
+                </a:solidFill>
+              </a:rPr>
+              <a:t>2025/05/22</a:t>
+            </a:r>
+          </a:p>
+        </p:txBody>
+      </p:sp>
+      <p:sp>
+        <p:nvSpPr>
+          <p:cNvPr id="6" name="Rectangle 5">
+            <a:extLst>
+              <a:ext uri="{FF2B5EF4-FFF2-40B4-BE49-F238E27FC236}">
+                <a16:creationId xmlns:a16="http://schemas.microsoft.com/office/drawing/2014/main" id="{8EEC52B7-373D-95A5-6FC8-715D7063FED3}"/>
+              </a:ext>
+            </a:extLst>
+          </p:cNvPr>
+          <p:cNvSpPr/>
+          <p:nvPr/>
+        </p:nvSpPr>
+        <p:spPr>
+          <a:xfrm>
+            <a:off x="11105810" y="6102026"/>
+            <a:ext cx="809837" cy="246221"/>
+          </a:xfrm>
+          <a:prstGeom prst="rect">
+            <a:avLst/>
+          </a:prstGeom>
+          <a:noFill/>
+        </p:spPr>
+        <p:txBody>
+          <a:bodyPr wrap="none" lIns="91440" tIns="45720" rIns="91440" bIns="45720">
+            <a:spAutoFit/>
+          </a:bodyPr>
+          <a:lstStyle/>
+          <a:p>
+            <a:pPr algn="ctr"/>
+            <a:r>
+              <a:rPr lang="en-US" sz="1000" b="0" cap="none" spc="0" dirty="0">
+                <a:ln w="0"/>
+                <a:solidFill>
+                  <a:srgbClr val="FF0000"/>
+                </a:solidFill>
+              </a:rPr>
+              <a:t>2025/05/22</a:t>
+            </a:r>
+          </a:p>
+        </p:txBody>
+      </p:sp>
     </p:spTree>
     <p:extLst>
       <p:ext uri="{BB962C8B-B14F-4D97-AF65-F5344CB8AC3E}">

</xml_diff>